<commit_message>
Extract PPTX speaker notes independent of Marker (0.1.15)
Found via a real conference deck with 324 words of speaker notes
across 12 slides: Marker's PowerPoint provider converts slides to a
PDF via rendered HTML and never touches notes, so they were silently
absent from every PPTX conversion, in both Markdown and chunk output.

Read directly from the source .pptx with python-pptx (already a
dependency - Marker's own provider uses it internally), independent
of Marker entirely, and attached under the slide they belong to:
"**Speaker notes:**" in Markdown, their own chunk with
section="Slide N" for --format rag. 100% of the notes' distinct words
recovered in both outputs on both real decks tested that have notes.

Adds notes to the self-generated sample.pptx fixture.
</commit_message>
<xml_diff>
--- a/tests/fixtures/sample.pptx
+++ b/tests/fixtures/sample.pptx
@@ -7,7 +7,7 @@
   <p:sldIdLst>
     <p:sldId id="256" r:id="rId7"/>
     <p:sldId id="257" r:id="rId8"/>
-    <p:sldId id="258" r:id="rId9"/>
+    <p:sldId id="258" r:id="rId10"/>
   </p:sldIdLst>
   <p:sldSz cx="9144000" cy="6858000" type="screen4x3"/>
   <p:notesSz cx="6858000" cy="9144000"/>
@@ -107,6 +107,426 @@
     </a:lvl9pPr>
   </p:defaultTextStyle>
 </p:presentation>
+</file>
+
+<file path=ppt/notesMasters/notesMaster1.xml><?xml version="1.0" encoding="utf-8"?>
+<p:notesMaster xmlns:a="http://schemas.openxmlformats.org/drawingml/2006/main" xmlns:p="http://schemas.openxmlformats.org/presentationml/2006/main" xmlns:r="http://schemas.openxmlformats.org/officeDocument/2006/relationships">
+  <p:cSld>
+    <p:bg>
+      <p:bgRef idx="1001">
+        <a:schemeClr val="bg1"/>
+      </p:bgRef>
+    </p:bg>
+    <p:spTree>
+      <p:nvGrpSpPr>
+        <p:cNvPr id="1" name=""/>
+        <p:cNvGrpSpPr/>
+        <p:nvPr/>
+      </p:nvGrpSpPr>
+      <p:grpSpPr>
+        <a:xfrm>
+          <a:off x="0" y="0"/>
+          <a:ext cx="0" cy="0"/>
+          <a:chOff x="0" y="0"/>
+          <a:chExt cx="0" cy="0"/>
+        </a:xfrm>
+      </p:grpSpPr>
+      <p:sp>
+        <p:nvSpPr>
+          <p:cNvPr id="2" name="Header Placeholder 1"/>
+          <p:cNvSpPr>
+            <a:spLocks noGrp="1"/>
+          </p:cNvSpPr>
+          <p:nvPr>
+            <p:ph type="hdr" sz="quarter"/>
+          </p:nvPr>
+        </p:nvSpPr>
+        <p:spPr>
+          <a:xfrm>
+            <a:off x="0" y="0"/>
+            <a:ext cx="2971800" cy="457200"/>
+          </a:xfrm>
+          <a:prstGeom prst="rect">
+            <a:avLst/>
+          </a:prstGeom>
+        </p:spPr>
+        <p:txBody>
+          <a:bodyPr vert="horz" lIns="91440" tIns="45720" rIns="91440" bIns="45720" rtlCol="0"/>
+          <a:lstStyle>
+            <a:lvl1pPr algn="l">
+              <a:defRPr sz="1200"/>
+            </a:lvl1pPr>
+          </a:lstStyle>
+          <a:p>
+            <a:endParaRPr lang="en-US"/>
+          </a:p>
+        </p:txBody>
+      </p:sp>
+      <p:sp>
+        <p:nvSpPr>
+          <p:cNvPr id="3" name="Date Placeholder 2"/>
+          <p:cNvSpPr>
+            <a:spLocks noGrp="1"/>
+          </p:cNvSpPr>
+          <p:nvPr>
+            <p:ph type="dt" idx="1"/>
+          </p:nvPr>
+        </p:nvSpPr>
+        <p:spPr>
+          <a:xfrm>
+            <a:off x="3884613" y="0"/>
+            <a:ext cx="2971800" cy="457200"/>
+          </a:xfrm>
+          <a:prstGeom prst="rect">
+            <a:avLst/>
+          </a:prstGeom>
+        </p:spPr>
+        <p:txBody>
+          <a:bodyPr vert="horz" lIns="91440" tIns="45720" rIns="91440" bIns="45720" rtlCol="0"/>
+          <a:lstStyle>
+            <a:lvl1pPr algn="r">
+              <a:defRPr sz="1200"/>
+            </a:lvl1pPr>
+          </a:lstStyle>
+          <a:p>
+            <a:fld id="{0F89C1C7-3DCD-1040-A9CF-14679D8B5DDD}" type="datetimeFigureOut">
+              <a:rPr lang="en-US" smtClean="0"/>
+              <a:t>10/17/16</a:t>
+            </a:fld>
+            <a:endParaRPr lang="en-US"/>
+          </a:p>
+        </p:txBody>
+      </p:sp>
+      <p:sp>
+        <p:nvSpPr>
+          <p:cNvPr id="4" name="Slide Image Placeholder 3"/>
+          <p:cNvSpPr>
+            <a:spLocks noGrp="1" noRot="1" noChangeAspect="1"/>
+          </p:cNvSpPr>
+          <p:nvPr>
+            <p:ph type="sldImg" idx="2"/>
+          </p:nvPr>
+        </p:nvSpPr>
+        <p:spPr>
+          <a:xfrm>
+            <a:off x="1143000" y="685800"/>
+            <a:ext cx="4572000" cy="3429000"/>
+          </a:xfrm>
+          <a:prstGeom prst="rect">
+            <a:avLst/>
+          </a:prstGeom>
+          <a:noFill/>
+          <a:ln w="12700">
+            <a:solidFill>
+              <a:prstClr val="black"/>
+            </a:solidFill>
+          </a:ln>
+        </p:spPr>
+        <p:txBody>
+          <a:bodyPr vert="horz" lIns="91440" tIns="45720" rIns="91440" bIns="45720" rtlCol="0" anchor="ctr"/>
+          <a:lstStyle/>
+          <a:p>
+            <a:endParaRPr lang="en-US"/>
+          </a:p>
+        </p:txBody>
+      </p:sp>
+      <p:sp>
+        <p:nvSpPr>
+          <p:cNvPr id="5" name="Notes Placeholder 4"/>
+          <p:cNvSpPr>
+            <a:spLocks noGrp="1"/>
+          </p:cNvSpPr>
+          <p:nvPr>
+            <p:ph type="body" sz="quarter" idx="3"/>
+          </p:nvPr>
+        </p:nvSpPr>
+        <p:spPr>
+          <a:xfrm>
+            <a:off x="685800" y="4343400"/>
+            <a:ext cx="5486400" cy="4114800"/>
+          </a:xfrm>
+          <a:prstGeom prst="rect">
+            <a:avLst/>
+          </a:prstGeom>
+        </p:spPr>
+        <p:txBody>
+          <a:bodyPr vert="horz" lIns="91440" tIns="45720" rIns="91440" bIns="45720" rtlCol="0"/>
+          <a:lstStyle/>
+          <a:p>
+            <a:pPr lvl="0"/>
+            <a:r>
+              <a:rPr lang="en-US" smtClean="0"/>
+              <a:t>Click to edit Master text styles</a:t>
+            </a:r>
+          </a:p>
+          <a:p>
+            <a:pPr lvl="1"/>
+            <a:r>
+              <a:rPr lang="en-US" smtClean="0"/>
+              <a:t>Second level</a:t>
+            </a:r>
+          </a:p>
+          <a:p>
+            <a:pPr lvl="2"/>
+            <a:r>
+              <a:rPr lang="en-US" smtClean="0"/>
+              <a:t>Third level</a:t>
+            </a:r>
+          </a:p>
+          <a:p>
+            <a:pPr lvl="3"/>
+            <a:r>
+              <a:rPr lang="en-US" smtClean="0"/>
+              <a:t>Fourth level</a:t>
+            </a:r>
+          </a:p>
+          <a:p>
+            <a:pPr lvl="4"/>
+            <a:r>
+              <a:rPr lang="en-US" smtClean="0"/>
+              <a:t>Fifth level</a:t>
+            </a:r>
+            <a:endParaRPr lang="en-US"/>
+          </a:p>
+        </p:txBody>
+      </p:sp>
+      <p:sp>
+        <p:nvSpPr>
+          <p:cNvPr id="6" name="Footer Placeholder 5"/>
+          <p:cNvSpPr>
+            <a:spLocks noGrp="1"/>
+          </p:cNvSpPr>
+          <p:nvPr>
+            <p:ph type="ftr" sz="quarter" idx="4"/>
+          </p:nvPr>
+        </p:nvSpPr>
+        <p:spPr>
+          <a:xfrm>
+            <a:off x="0" y="8685213"/>
+            <a:ext cx="2971800" cy="457200"/>
+          </a:xfrm>
+          <a:prstGeom prst="rect">
+            <a:avLst/>
+          </a:prstGeom>
+        </p:spPr>
+        <p:txBody>
+          <a:bodyPr vert="horz" lIns="91440" tIns="45720" rIns="91440" bIns="45720" rtlCol="0" anchor="b"/>
+          <a:lstStyle>
+            <a:lvl1pPr algn="l">
+              <a:defRPr sz="1200"/>
+            </a:lvl1pPr>
+          </a:lstStyle>
+          <a:p>
+            <a:endParaRPr lang="en-US"/>
+          </a:p>
+        </p:txBody>
+      </p:sp>
+      <p:sp>
+        <p:nvSpPr>
+          <p:cNvPr id="7" name="Slide Number Placeholder 6"/>
+          <p:cNvSpPr>
+            <a:spLocks noGrp="1"/>
+          </p:cNvSpPr>
+          <p:nvPr>
+            <p:ph type="sldNum" sz="quarter" idx="5"/>
+          </p:nvPr>
+        </p:nvSpPr>
+        <p:spPr>
+          <a:xfrm>
+            <a:off x="3884613" y="8685213"/>
+            <a:ext cx="2971800" cy="457200"/>
+          </a:xfrm>
+          <a:prstGeom prst="rect">
+            <a:avLst/>
+          </a:prstGeom>
+        </p:spPr>
+        <p:txBody>
+          <a:bodyPr vert="horz" lIns="91440" tIns="45720" rIns="91440" bIns="45720" rtlCol="0" anchor="b"/>
+          <a:lstStyle>
+            <a:lvl1pPr algn="r">
+              <a:defRPr sz="1200"/>
+            </a:lvl1pPr>
+          </a:lstStyle>
+          <a:p>
+            <a:fld id="{BB5E49A5-4136-284D-997B-48E1D791AD67}" type="slidenum">
+              <a:rPr lang="en-US" smtClean="0"/>
+              <a:t>‹#›</a:t>
+            </a:fld>
+            <a:endParaRPr lang="en-US"/>
+          </a:p>
+        </p:txBody>
+      </p:sp>
+    </p:spTree>
+    <p:extLst>
+      <p:ext uri="{BB962C8B-B14F-4D97-AF65-F5344CB8AC3E}">
+        <p14:creationId xmlns:p14="http://schemas.microsoft.com/office/powerpoint/2010/main" val="2623252185"/>
+      </p:ext>
+    </p:extLst>
+  </p:cSld>
+  <p:clrMap bg1="lt1" tx1="dk1" bg2="lt2" tx2="dk2" accent1="accent1" accent2="accent2" accent3="accent3" accent4="accent4" accent5="accent5" accent6="accent6" hlink="hlink" folHlink="folHlink"/>
+  <p:notesStyle>
+    <a:lvl1pPr marL="0" algn="l" defTabSz="457200" rtl="0" eaLnBrk="1" latinLnBrk="0" hangingPunct="1">
+      <a:defRPr sz="1200" kern="1200">
+        <a:solidFill>
+          <a:schemeClr val="tx1"/>
+        </a:solidFill>
+        <a:latin typeface="+mn-lt"/>
+        <a:ea typeface="+mn-ea"/>
+        <a:cs typeface="+mn-cs"/>
+      </a:defRPr>
+    </a:lvl1pPr>
+    <a:lvl2pPr marL="457200" algn="l" defTabSz="457200" rtl="0" eaLnBrk="1" latinLnBrk="0" hangingPunct="1">
+      <a:defRPr sz="1200" kern="1200">
+        <a:solidFill>
+          <a:schemeClr val="tx1"/>
+        </a:solidFill>
+        <a:latin typeface="+mn-lt"/>
+        <a:ea typeface="+mn-ea"/>
+        <a:cs typeface="+mn-cs"/>
+      </a:defRPr>
+    </a:lvl2pPr>
+    <a:lvl3pPr marL="914400" algn="l" defTabSz="457200" rtl="0" eaLnBrk="1" latinLnBrk="0" hangingPunct="1">
+      <a:defRPr sz="1200" kern="1200">
+        <a:solidFill>
+          <a:schemeClr val="tx1"/>
+        </a:solidFill>
+        <a:latin typeface="+mn-lt"/>
+        <a:ea typeface="+mn-ea"/>
+        <a:cs typeface="+mn-cs"/>
+      </a:defRPr>
+    </a:lvl3pPr>
+    <a:lvl4pPr marL="1371600" algn="l" defTabSz="457200" rtl="0" eaLnBrk="1" latinLnBrk="0" hangingPunct="1">
+      <a:defRPr sz="1200" kern="1200">
+        <a:solidFill>
+          <a:schemeClr val="tx1"/>
+        </a:solidFill>
+        <a:latin typeface="+mn-lt"/>
+        <a:ea typeface="+mn-ea"/>
+        <a:cs typeface="+mn-cs"/>
+      </a:defRPr>
+    </a:lvl4pPr>
+    <a:lvl5pPr marL="1828800" algn="l" defTabSz="457200" rtl="0" eaLnBrk="1" latinLnBrk="0" hangingPunct="1">
+      <a:defRPr sz="1200" kern="1200">
+        <a:solidFill>
+          <a:schemeClr val="tx1"/>
+        </a:solidFill>
+        <a:latin typeface="+mn-lt"/>
+        <a:ea typeface="+mn-ea"/>
+        <a:cs typeface="+mn-cs"/>
+      </a:defRPr>
+    </a:lvl5pPr>
+    <a:lvl6pPr marL="2286000" algn="l" defTabSz="457200" rtl="0" eaLnBrk="1" latinLnBrk="0" hangingPunct="1">
+      <a:defRPr sz="1200" kern="1200">
+        <a:solidFill>
+          <a:schemeClr val="tx1"/>
+        </a:solidFill>
+        <a:latin typeface="+mn-lt"/>
+        <a:ea typeface="+mn-ea"/>
+        <a:cs typeface="+mn-cs"/>
+      </a:defRPr>
+    </a:lvl6pPr>
+    <a:lvl7pPr marL="2743200" algn="l" defTabSz="457200" rtl="0" eaLnBrk="1" latinLnBrk="0" hangingPunct="1">
+      <a:defRPr sz="1200" kern="1200">
+        <a:solidFill>
+          <a:schemeClr val="tx1"/>
+        </a:solidFill>
+        <a:latin typeface="+mn-lt"/>
+        <a:ea typeface="+mn-ea"/>
+        <a:cs typeface="+mn-cs"/>
+      </a:defRPr>
+    </a:lvl7pPr>
+    <a:lvl8pPr marL="3200400" algn="l" defTabSz="457200" rtl="0" eaLnBrk="1" latinLnBrk="0" hangingPunct="1">
+      <a:defRPr sz="1200" kern="1200">
+        <a:solidFill>
+          <a:schemeClr val="tx1"/>
+        </a:solidFill>
+        <a:latin typeface="+mn-lt"/>
+        <a:ea typeface="+mn-ea"/>
+        <a:cs typeface="+mn-cs"/>
+      </a:defRPr>
+    </a:lvl8pPr>
+    <a:lvl9pPr marL="3657600" algn="l" defTabSz="457200" rtl="0" eaLnBrk="1" latinLnBrk="0" hangingPunct="1">
+      <a:defRPr sz="1200" kern="1200">
+        <a:solidFill>
+          <a:schemeClr val="tx1"/>
+        </a:solidFill>
+        <a:latin typeface="+mn-lt"/>
+        <a:ea typeface="+mn-ea"/>
+        <a:cs typeface="+mn-cs"/>
+      </a:defRPr>
+    </a:lvl9pPr>
+  </p:notesStyle>
+</p:notesMaster>
+</file>
+
+<file path=ppt/notesSlides/notesSlide1.xml><?xml version="1.0" encoding="utf-8"?>
+<p:notes xmlns:a="http://schemas.openxmlformats.org/drawingml/2006/main" xmlns:p="http://schemas.openxmlformats.org/presentationml/2006/main" xmlns:r="http://schemas.openxmlformats.org/officeDocument/2006/relationships">
+  <p:cSld>
+    <p:spTree>
+      <p:nvGrpSpPr>
+        <p:cNvPr id="1" name=""/>
+        <p:cNvGrpSpPr/>
+        <p:nvPr/>
+      </p:nvGrpSpPr>
+      <p:grpSpPr>
+        <a:xfrm>
+          <a:off x="0" y="0"/>
+          <a:ext cx="0" cy="0"/>
+          <a:chOff x="0" y="0"/>
+          <a:chExt cx="0" cy="0"/>
+        </a:xfrm>
+      </p:grpSpPr>
+      <p:sp>
+        <p:nvSpPr>
+          <p:cNvPr id="2" name="Slide Image Placeholder 1"/>
+          <p:cNvSpPr>
+            <a:spLocks noGrp="1"/>
+          </p:cNvSpPr>
+          <p:nvPr>
+            <p:ph type="sldImg" idx="2"/>
+          </p:nvPr>
+        </p:nvSpPr>
+        <p:spPr/>
+      </p:sp>
+      <p:sp>
+        <p:nvSpPr>
+          <p:cNvPr id="3" name="Notes Placeholder 2"/>
+          <p:cNvSpPr>
+            <a:spLocks noGrp="1"/>
+          </p:cNvSpPr>
+          <p:nvPr>
+            <p:ph type="body" idx="3" sz="quarter"/>
+          </p:nvPr>
+        </p:nvSpPr>
+        <p:spPr/>
+        <p:txBody>
+          <a:bodyPr/>
+          <a:lstStyle/>
+          <a:p>
+            <a:r>
+              <a:t>Presenter context: the churn figure excludes self-serve accounts, which improved independently this quarter.</a:t>
+            </a:r>
+          </a:p>
+        </p:txBody>
+      </p:sp>
+      <p:sp>
+        <p:nvSpPr>
+          <p:cNvPr id="4" name="Slide Number Placeholder 3"/>
+          <p:cNvSpPr>
+            <a:spLocks noGrp="1"/>
+          </p:cNvSpPr>
+          <p:nvPr>
+            <p:ph type="sldNum" idx="5" sz="quarter"/>
+          </p:nvPr>
+        </p:nvSpPr>
+        <p:spPr/>
+      </p:sp>
+    </p:spTree>
+  </p:cSld>
+  <p:clrMapOvr>
+    <a:masterClrMapping/>
+  </p:clrMapOvr>
+</p:notes>
 </file>
 
 <file path=ppt/slideLayouts/slideLayout1.xml><?xml version="1.0" encoding="utf-8"?>
@@ -3593,4 +4013,324 @@
   </a:objectDefaults>
   <a:extraClrSchemeLst/>
 </a:theme>
+</file>
+
+<file path=ppt/theme/theme2.xml><?xml version="1.0" encoding="utf-8"?>
+<a:theme xmlns:a="http://schemas.openxmlformats.org/drawingml/2006/main" name="Office Theme">
+  <a:themeElements>
+    <a:clrScheme name="Office">
+      <a:dk1>
+        <a:sysClr val="windowText" lastClr="000000"/>
+      </a:dk1>
+      <a:lt1>
+        <a:sysClr val="window" lastClr="FFFFFF"/>
+      </a:lt1>
+      <a:dk2>
+        <a:srgbClr val="1F497D"/>
+      </a:dk2>
+      <a:lt2>
+        <a:srgbClr val="EEECE1"/>
+      </a:lt2>
+      <a:accent1>
+        <a:srgbClr val="4F81BD"/>
+      </a:accent1>
+      <a:accent2>
+        <a:srgbClr val="C0504D"/>
+      </a:accent2>
+      <a:accent3>
+        <a:srgbClr val="9BBB59"/>
+      </a:accent3>
+      <a:accent4>
+        <a:srgbClr val="8064A2"/>
+      </a:accent4>
+      <a:accent5>
+        <a:srgbClr val="4BACC6"/>
+      </a:accent5>
+      <a:accent6>
+        <a:srgbClr val="F79646"/>
+      </a:accent6>
+      <a:hlink>
+        <a:srgbClr val="0000FF"/>
+      </a:hlink>
+      <a:folHlink>
+        <a:srgbClr val="800080"/>
+      </a:folHlink>
+    </a:clrScheme>
+    <a:fontScheme name="Office">
+      <a:majorFont>
+        <a:latin typeface="Calibri"/>
+        <a:ea typeface=""/>
+        <a:cs typeface=""/>
+        <a:font script="Jpan" typeface="ＭＳ Ｐゴシック"/>
+        <a:font script="Hang" typeface="맑은 고딕"/>
+        <a:font script="Hans" typeface="宋体"/>
+        <a:font script="Hant" typeface="新細明體"/>
+        <a:font script="Arab" typeface="Times New Roman"/>
+        <a:font script="Hebr" typeface="Times New Roman"/>
+        <a:font script="Thai" typeface="Angsana New"/>
+        <a:font script="Ethi" typeface="Nyala"/>
+        <a:font script="Beng" typeface="Vrinda"/>
+        <a:font script="Gujr" typeface="Shruti"/>
+        <a:font script="Khmr" typeface="MoolBoran"/>
+        <a:font script="Knda" typeface="Tunga"/>
+        <a:font script="Guru" typeface="Raavi"/>
+        <a:font script="Cans" typeface="Euphemia"/>
+        <a:font script="Cher" typeface="Plantagenet Cherokee"/>
+        <a:font script="Yiii" typeface="Microsoft Yi Baiti"/>
+        <a:font script="Tibt" typeface="Microsoft Himalaya"/>
+        <a:font script="Thaa" typeface="MV Boli"/>
+        <a:font script="Deva" typeface="Mangal"/>
+        <a:font script="Telu" typeface="Gautami"/>
+        <a:font script="Taml" typeface="Latha"/>
+        <a:font script="Syrc" typeface="Estrangelo Edessa"/>
+        <a:font script="Orya" typeface="Kalinga"/>
+        <a:font script="Mlym" typeface="Kartika"/>
+        <a:font script="Laoo" typeface="DokChampa"/>
+        <a:font script="Sinh" typeface="Iskoola Pota"/>
+        <a:font script="Mong" typeface="Mongolian Baiti"/>
+        <a:font script="Viet" typeface="Times New Roman"/>
+        <a:font script="Uigh" typeface="Microsoft Uighur"/>
+        <a:font script="Geor" typeface="Sylfaen"/>
+      </a:majorFont>
+      <a:minorFont>
+        <a:latin typeface="Calibri"/>
+        <a:ea typeface=""/>
+        <a:cs typeface=""/>
+        <a:font script="Jpan" typeface="ＭＳ Ｐゴシック"/>
+        <a:font script="Hang" typeface="맑은 고딕"/>
+        <a:font script="Hans" typeface="宋体"/>
+        <a:font script="Hant" typeface="新細明體"/>
+        <a:font script="Arab" typeface="Arial"/>
+        <a:font script="Hebr" typeface="Arial"/>
+        <a:font script="Thai" typeface="Cordia New"/>
+        <a:font script="Ethi" typeface="Nyala"/>
+        <a:font script="Beng" typeface="Vrinda"/>
+        <a:font script="Gujr" typeface="Shruti"/>
+        <a:font script="Khmr" typeface="DaunPenh"/>
+        <a:font script="Knda" typeface="Tunga"/>
+        <a:font script="Guru" typeface="Raavi"/>
+        <a:font script="Cans" typeface="Euphemia"/>
+        <a:font script="Cher" typeface="Plantagenet Cherokee"/>
+        <a:font script="Yiii" typeface="Microsoft Yi Baiti"/>
+        <a:font script="Tibt" typeface="Microsoft Himalaya"/>
+        <a:font script="Thaa" typeface="MV Boli"/>
+        <a:font script="Deva" typeface="Mangal"/>
+        <a:font script="Telu" typeface="Gautami"/>
+        <a:font script="Taml" typeface="Latha"/>
+        <a:font script="Syrc" typeface="Estrangelo Edessa"/>
+        <a:font script="Orya" typeface="Kalinga"/>
+        <a:font script="Mlym" typeface="Kartika"/>
+        <a:font script="Laoo" typeface="DokChampa"/>
+        <a:font script="Sinh" typeface="Iskoola Pota"/>
+        <a:font script="Mong" typeface="Mongolian Baiti"/>
+        <a:font script="Viet" typeface="Arial"/>
+        <a:font script="Uigh" typeface="Microsoft Uighur"/>
+        <a:font script="Geor" typeface="Sylfaen"/>
+      </a:minorFont>
+    </a:fontScheme>
+    <a:fmtScheme name="Office">
+      <a:fillStyleLst>
+        <a:solidFill>
+          <a:schemeClr val="phClr"/>
+        </a:solidFill>
+        <a:gradFill rotWithShape="1">
+          <a:gsLst>
+            <a:gs pos="0">
+              <a:schemeClr val="phClr">
+                <a:tint val="50000"/>
+                <a:satMod val="300000"/>
+              </a:schemeClr>
+            </a:gs>
+            <a:gs pos="35000">
+              <a:schemeClr val="phClr">
+                <a:tint val="37000"/>
+                <a:satMod val="300000"/>
+              </a:schemeClr>
+            </a:gs>
+            <a:gs pos="100000">
+              <a:schemeClr val="phClr">
+                <a:tint val="15000"/>
+                <a:satMod val="350000"/>
+              </a:schemeClr>
+            </a:gs>
+          </a:gsLst>
+          <a:lin ang="16200000" scaled="1"/>
+        </a:gradFill>
+        <a:gradFill rotWithShape="1">
+          <a:gsLst>
+            <a:gs pos="0">
+              <a:schemeClr val="phClr">
+                <a:tint val="100000"/>
+                <a:shade val="100000"/>
+                <a:satMod val="130000"/>
+              </a:schemeClr>
+            </a:gs>
+            <a:gs pos="100000">
+              <a:schemeClr val="phClr">
+                <a:tint val="50000"/>
+                <a:shade val="100000"/>
+                <a:satMod val="350000"/>
+              </a:schemeClr>
+            </a:gs>
+          </a:gsLst>
+          <a:lin ang="16200000" scaled="0"/>
+        </a:gradFill>
+      </a:fillStyleLst>
+      <a:lnStyleLst>
+        <a:ln w="9525" cap="flat" cmpd="sng" algn="ctr">
+          <a:solidFill>
+            <a:schemeClr val="phClr">
+              <a:shade val="95000"/>
+              <a:satMod val="105000"/>
+            </a:schemeClr>
+          </a:solidFill>
+          <a:prstDash val="solid"/>
+        </a:ln>
+        <a:ln w="25400" cap="flat" cmpd="sng" algn="ctr">
+          <a:solidFill>
+            <a:schemeClr val="phClr"/>
+          </a:solidFill>
+          <a:prstDash val="solid"/>
+        </a:ln>
+        <a:ln w="38100" cap="flat" cmpd="sng" algn="ctr">
+          <a:solidFill>
+            <a:schemeClr val="phClr"/>
+          </a:solidFill>
+          <a:prstDash val="solid"/>
+        </a:ln>
+      </a:lnStyleLst>
+      <a:effectStyleLst>
+        <a:effectStyle>
+          <a:effectLst>
+            <a:outerShdw blurRad="40000" dist="20000" dir="5400000" rotWithShape="0">
+              <a:srgbClr val="000000">
+                <a:alpha val="38000"/>
+              </a:srgbClr>
+            </a:outerShdw>
+          </a:effectLst>
+        </a:effectStyle>
+        <a:effectStyle>
+          <a:effectLst>
+            <a:outerShdw blurRad="40000" dist="23000" dir="5400000" rotWithShape="0">
+              <a:srgbClr val="000000">
+                <a:alpha val="35000"/>
+              </a:srgbClr>
+            </a:outerShdw>
+          </a:effectLst>
+        </a:effectStyle>
+        <a:effectStyle>
+          <a:effectLst>
+            <a:outerShdw blurRad="40000" dist="23000" dir="5400000" rotWithShape="0">
+              <a:srgbClr val="000000">
+                <a:alpha val="35000"/>
+              </a:srgbClr>
+            </a:outerShdw>
+          </a:effectLst>
+          <a:scene3d>
+            <a:camera prst="orthographicFront">
+              <a:rot lat="0" lon="0" rev="0"/>
+            </a:camera>
+            <a:lightRig rig="threePt" dir="t">
+              <a:rot lat="0" lon="0" rev="1200000"/>
+            </a:lightRig>
+          </a:scene3d>
+          <a:sp3d>
+            <a:bevelT w="63500" h="25400"/>
+          </a:sp3d>
+        </a:effectStyle>
+      </a:effectStyleLst>
+      <a:bgFillStyleLst>
+        <a:solidFill>
+          <a:schemeClr val="phClr"/>
+        </a:solidFill>
+        <a:gradFill rotWithShape="1">
+          <a:gsLst>
+            <a:gs pos="0">
+              <a:schemeClr val="phClr">
+                <a:tint val="40000"/>
+                <a:satMod val="350000"/>
+              </a:schemeClr>
+            </a:gs>
+            <a:gs pos="40000">
+              <a:schemeClr val="phClr">
+                <a:tint val="45000"/>
+                <a:shade val="99000"/>
+                <a:satMod val="350000"/>
+              </a:schemeClr>
+            </a:gs>
+            <a:gs pos="100000">
+              <a:schemeClr val="phClr">
+                <a:shade val="20000"/>
+                <a:satMod val="255000"/>
+              </a:schemeClr>
+            </a:gs>
+          </a:gsLst>
+          <a:path path="circle">
+            <a:fillToRect l="50000" t="-80000" r="50000" b="180000"/>
+          </a:path>
+        </a:gradFill>
+        <a:gradFill rotWithShape="1">
+          <a:gsLst>
+            <a:gs pos="0">
+              <a:schemeClr val="phClr">
+                <a:tint val="80000"/>
+                <a:satMod val="300000"/>
+              </a:schemeClr>
+            </a:gs>
+            <a:gs pos="100000">
+              <a:schemeClr val="phClr">
+                <a:shade val="30000"/>
+                <a:satMod val="200000"/>
+              </a:schemeClr>
+            </a:gs>
+          </a:gsLst>
+          <a:path path="circle">
+            <a:fillToRect l="50000" t="50000" r="50000" b="50000"/>
+          </a:path>
+        </a:gradFill>
+      </a:bgFillStyleLst>
+    </a:fmtScheme>
+  </a:themeElements>
+  <a:objectDefaults>
+    <a:spDef>
+      <a:spPr/>
+      <a:bodyPr/>
+      <a:lstStyle/>
+      <a:style>
+        <a:lnRef idx="1">
+          <a:schemeClr val="accent1"/>
+        </a:lnRef>
+        <a:fillRef idx="3">
+          <a:schemeClr val="accent1"/>
+        </a:fillRef>
+        <a:effectRef idx="2">
+          <a:schemeClr val="accent1"/>
+        </a:effectRef>
+        <a:fontRef idx="minor">
+          <a:schemeClr val="lt1"/>
+        </a:fontRef>
+      </a:style>
+    </a:spDef>
+    <a:lnDef>
+      <a:spPr/>
+      <a:bodyPr/>
+      <a:lstStyle/>
+      <a:style>
+        <a:lnRef idx="2">
+          <a:schemeClr val="accent1"/>
+        </a:lnRef>
+        <a:fillRef idx="0">
+          <a:schemeClr val="accent1"/>
+        </a:fillRef>
+        <a:effectRef idx="1">
+          <a:schemeClr val="accent1"/>
+        </a:effectRef>
+        <a:fontRef idx="minor">
+          <a:schemeClr val="tx1"/>
+        </a:fontRef>
+      </a:style>
+    </a:lnDef>
+  </a:objectDefaults>
+  <a:extraClrSchemeLst/>
+</a:theme>
 </file>
</xml_diff>